<commit_message>
Fix ./Presentacion_entrega_2.pptx version final
</commit_message>
<xml_diff>
--- a/Presentacion_entrega_2.pptx
+++ b/Presentacion_entrega_2.pptx
@@ -1481,7 +1481,7 @@
         </p:nvSpPr>
         <p:spPr>
           <a:xfrm>
-            <a:off x="381300" y="685800"/>
+            <a:off x="381000" y="685800"/>
             <a:ext cx="6096000" cy="3429000"/>
           </a:xfrm>
           <a:custGeom>
@@ -7154,10 +7154,10 @@
               <a:buNone/>
             </a:pPr>
             <a:r>
-              <a:rPr lang="es" sz="4500"/>
+              <a:rPr lang="es" sz="4500" dirty="0"/>
               <a:t>Consecuencias de la IA en las personas</a:t>
             </a:r>
-            <a:endParaRPr sz="4500"/>
+            <a:endParaRPr sz="4500" dirty="0"/>
           </a:p>
         </p:txBody>
       </p:sp>
@@ -8350,14 +8350,17 @@
               <a:buNone/>
             </a:pPr>
             <a:r>
-              <a:rPr lang="es" sz="2300" b="1" dirty="0">
+              <a:rPr lang="es" sz="2300" dirty="0">
                 <a:solidFill>
                   <a:schemeClr val="dk1"/>
                 </a:solidFill>
+                <a:latin typeface="Economica" panose="020B0604020202020204" charset="0"/>
               </a:rPr>
               <a:t>Preocupaciones frente a la IA</a:t>
             </a:r>
-            <a:endParaRPr dirty="0"/>
+            <a:endParaRPr dirty="0">
+              <a:latin typeface="Economica" panose="020B0604020202020204" charset="0"/>
+            </a:endParaRPr>
           </a:p>
         </p:txBody>
       </p:sp>
@@ -8598,7 +8601,7 @@
         <p:spPr>
           <a:xfrm>
             <a:off x="2330250" y="285175"/>
-            <a:ext cx="4483500" cy="1075649"/>
+            <a:ext cx="4483500" cy="668614"/>
           </a:xfrm>
           <a:prstGeom prst="rect">
             <a:avLst/>
@@ -8627,14 +8630,17 @@
               <a:buNone/>
             </a:pPr>
             <a:r>
-              <a:rPr lang="es" sz="2300" b="1" dirty="0">
+              <a:rPr lang="es" sz="2300" dirty="0">
                 <a:solidFill>
                   <a:schemeClr val="dk1"/>
                 </a:solidFill>
+                <a:latin typeface="Economica" panose="020B0604020202020204" charset="0"/>
               </a:rPr>
               <a:t>Producción de publicaciones científicas de IA</a:t>
             </a:r>
-            <a:endParaRPr dirty="0"/>
+            <a:endParaRPr dirty="0">
+              <a:latin typeface="Economica" panose="020B0604020202020204" charset="0"/>
+            </a:endParaRPr>
           </a:p>
         </p:txBody>
       </p:sp>
@@ -8698,10 +8704,10 @@
               <a:buNone/>
             </a:pPr>
             <a:r>
-              <a:rPr lang="es" sz="4600"/>
+              <a:rPr lang="es" sz="4600" dirty="0"/>
               <a:t>Discusión</a:t>
             </a:r>
-            <a:endParaRPr sz="4600"/>
+            <a:endParaRPr sz="4600" dirty="0"/>
           </a:p>
         </p:txBody>
       </p:sp>
@@ -8714,7 +8720,7 @@
         <p:spPr>
           <a:xfrm>
             <a:off x="486525" y="1466125"/>
-            <a:ext cx="8274600" cy="1545300"/>
+            <a:ext cx="8274600" cy="1731213"/>
           </a:xfrm>
           <a:prstGeom prst="rect">
             <a:avLst/>
@@ -8743,17 +8749,19 @@
               <a:buNone/>
             </a:pPr>
             <a:r>
-              <a:rPr lang="es">
+              <a:rPr lang="es" dirty="0">
                 <a:solidFill>
                   <a:schemeClr val="dk1"/>
                 </a:solidFill>
+                <a:latin typeface="Economica" panose="020B0604020202020204" charset="0"/>
               </a:rPr>
               <a:t>Para concluir el análisis de esta entrega, destacamos los siguientes hallazgos reveladores:</a:t>
             </a:r>
-            <a:endParaRPr>
+            <a:endParaRPr dirty="0">
               <a:solidFill>
                 <a:schemeClr val="dk1"/>
               </a:solidFill>
+              <a:latin typeface="Economica" panose="020B0604020202020204" charset="0"/>
             </a:endParaRPr>
           </a:p>
           <a:p>
@@ -8774,17 +8782,19 @@
               <a:buChar char="●"/>
             </a:pPr>
             <a:r>
-              <a:rPr lang="es" b="1">
+              <a:rPr lang="es" b="1" dirty="0">
                 <a:solidFill>
                   <a:schemeClr val="dk1"/>
                 </a:solidFill>
+                <a:latin typeface="Economica" panose="020B0604020202020204" charset="0"/>
               </a:rPr>
               <a:t>Percepción </a:t>
             </a:r>
-            <a:endParaRPr b="1">
+            <a:endParaRPr b="1" dirty="0">
               <a:solidFill>
                 <a:schemeClr val="dk1"/>
               </a:solidFill>
+              <a:latin typeface="Economica" panose="020B0604020202020204" charset="0"/>
             </a:endParaRPr>
           </a:p>
           <a:p>
@@ -8805,17 +8815,19 @@
               <a:buChar char="●"/>
             </a:pPr>
             <a:r>
-              <a:rPr lang="es" b="1">
+              <a:rPr lang="es" b="1" dirty="0">
                 <a:solidFill>
                   <a:schemeClr val="dk1"/>
                 </a:solidFill>
+                <a:latin typeface="Economica" panose="020B0604020202020204" charset="0"/>
               </a:rPr>
               <a:t>Impacto laboral</a:t>
             </a:r>
-            <a:endParaRPr b="1">
+            <a:endParaRPr b="1" dirty="0">
               <a:solidFill>
                 <a:schemeClr val="dk1"/>
               </a:solidFill>
+              <a:latin typeface="Economica" panose="020B0604020202020204" charset="0"/>
             </a:endParaRPr>
           </a:p>
           <a:p>
@@ -8836,17 +8848,19 @@
               <a:buChar char="●"/>
             </a:pPr>
             <a:r>
-              <a:rPr lang="es" b="1">
+              <a:rPr lang="es" b="1" dirty="0">
                 <a:solidFill>
                   <a:schemeClr val="dk1"/>
                 </a:solidFill>
+                <a:latin typeface="Economica" panose="020B0604020202020204" charset="0"/>
               </a:rPr>
               <a:t>Efecto en la educación</a:t>
             </a:r>
-            <a:endParaRPr>
+            <a:endParaRPr dirty="0">
               <a:solidFill>
                 <a:schemeClr val="dk1"/>
               </a:solidFill>
+              <a:latin typeface="Economica" panose="020B0604020202020204" charset="0"/>
             </a:endParaRPr>
           </a:p>
           <a:p>
@@ -8867,17 +8881,19 @@
               <a:buChar char="●"/>
             </a:pPr>
             <a:r>
-              <a:rPr lang="es" b="1">
+              <a:rPr lang="es" b="1" dirty="0">
                 <a:solidFill>
                   <a:schemeClr val="dk1"/>
                 </a:solidFill>
+                <a:latin typeface="Economica" panose="020B0604020202020204" charset="0"/>
               </a:rPr>
               <a:t>Hegemonía tecnológica global</a:t>
             </a:r>
-            <a:endParaRPr>
+            <a:endParaRPr dirty="0">
               <a:solidFill>
                 <a:schemeClr val="dk1"/>
               </a:solidFill>
+              <a:latin typeface="Economica" panose="020B0604020202020204" charset="0"/>
             </a:endParaRPr>
           </a:p>
         </p:txBody>

</xml_diff>